<commit_message>
Rework PPTX preview rendering for theme backgrounds, images, and shapes
Replace the PPTX preview's parser and renderer with a DOM-based OOXML
reader that follows the slide/layout/master/theme inheritance chain:
positional theme style references (fixes #99), gradient/picture/pattern
fills, outlines, preset and custom geometry, text styles and bullets,
tables, charts, SmartArt drawings, and EMF/WMF images through the
lazily-loaded rtf.js renderers (fixes #97).
</commit_message>
<xml_diff>
--- a/ui/src/test-fixtures/theme-bgref.pptx
+++ b/ui/src/test-fixtures/theme-bgref.pptx
@@ -9,17 +9,44 @@
 </p:presentation>
 </file>
 
-<file path=ppt/slideLayouts/slideLayout1.xml><?xml version="1.0" encoding="UTF-8" standalone="yes"?>
+<file path=ppt/slideLayouts/slideLayout1.xml><?xml version="1.0" encoding="utf-8"?>
 <p:sldLayout xmlns:a="http://schemas.openxmlformats.org/drawingml/2006/main" xmlns:r="http://schemas.openxmlformats.org/officeDocument/2006/relationships" xmlns:p="http://schemas.openxmlformats.org/presentationml/2006/main">
-<p:cSld><p:bg><p:bgRef idx="1001"><a:schemeClr val="accent1"/></a:bgRef></p:bg><p:spTree>
-<p:nvGrpSpPr><p:cNvPr id="1" name=""/><p:cNvGrpSpPr/><p:nvPr/></p:nvGrpSpPr>
-<p:grpSpPr/>
-<p:sp>
-<p:nvSpPr><p:cNvPr id="2" name="Title Placeholder 1"/><p:cNvSpPr><a:spLocks noGrp="1"/></p:cNvSpPr><p:nvPr><p:ph type="title"/></p:nvPr></p:nvSpPr>
-<p:spPr><a:xfrm><a:off x="400000" y="400000"/><a:ext cx="4000000" cy="800000"/></a:xfrm></p:spPr>
-<p:txBody><a:bodyPr/><a:p/></p:txBody>
-</p:sp>
-</p:spTree></p:cSld>
+  <p:cSld>
+    <p:bg>
+      <p:bgRef idx="1001">
+        <a:schemeClr val="accent1"/>
+      </p:bgRef>
+    </p:bg>
+    <p:spTree>
+      <p:nvGrpSpPr>
+        <p:cNvPr id="1" name=""/>
+        <p:cNvGrpSpPr/>
+        <p:nvPr/>
+      </p:nvGrpSpPr>
+      <p:grpSpPr/>
+      <p:sp>
+        <p:nvSpPr>
+          <p:cNvPr id="2" name="Title Placeholder 1"/>
+          <p:cNvSpPr>
+            <a:spLocks noGrp="1"/>
+          </p:cNvSpPr>
+          <p:nvPr>
+            <p:ph type="title"/>
+          </p:nvPr>
+        </p:nvSpPr>
+        <p:spPr>
+          <a:xfrm>
+            <a:off x="400000" y="400000"/>
+            <a:ext cx="4000000" cy="800000"/>
+          </a:xfrm>
+        </p:spPr>
+        <p:txBody>
+          <a:bodyPr/>
+          <a:p/>
+        </p:txBody>
+      </p:sp>
+    </p:spTree>
+  </p:cSld>
 </p:sldLayout>
 </file>
 

</xml_diff>